<commit_message>
fix(slides): fix 16:9 widescreen canvas boundaries and element positioning
</commit_message>
<xml_diff>
--- a/myslides/slides.pptx
+++ b/myslides/slides.pptx
@@ -31,8 +31,8 @@
   <p:notesMasterIdLst>
     <p:notesMasterId r:id="rId24"/>
   </p:notesMasterIdLst>
-  <p:sldSz cx="9144000" cy="5143500"/>
-  <p:notesSz cx="5143500" cy="9144000"/>
+  <p:sldSz cx="12191695" cy="6858000"/>
+  <p:notesSz cx="6858000" cy="12191695"/>
   <p:defaultTextStyle>
     <a:lvl1pPr marL="0" algn="l" defTabSz="914400" rtl="0" eaLnBrk="1" latinLnBrk="0" hangingPunct="1">
       <a:defRPr sz="1800" kern="1200">

</xml_diff>